<commit_message>
Docs and C-batch deck for PyPI 0.1.4 release
Update README/ABSTRACT/TECHNICAL_DESIGN with limits and security status;
regenerate PromptCapsule_CBatch.pptx for v0.1.4.

Co-authored-by: Cursor <cursoragent@cursor.com>
</commit_message>
<xml_diff>
--- a/presentation/PromptCapsule_CBatch.pptx
+++ b/presentation/PromptCapsule_CBatch.pptx
@@ -3240,13 +3240,13 @@
           <a:p>
             <a:pPr algn="l"/>
             <a:r>
-              <a:rPr sz="2600" b="0">
+              <a:rPr sz="2400" b="0">
                 <a:solidFill>
                   <a:srgbClr val="14B8A6"/>
                 </a:solidFill>
                 <a:latin typeface="Calibri"/>
               </a:rPr>
-              <a:t>Lossless Prompt Packaging &amp; Retrieval</a:t>
+              <a:t>Lossless Prompt Packaging &amp; Retrieval  ·  v0.1.4</a:t>
             </a:r>
           </a:p>
         </p:txBody>
@@ -3281,7 +3281,7 @@
                 </a:solidFill>
                 <a:latin typeface="Calibri"/>
               </a:rPr>
-              <a:t>C-Batch Technical Brief  ·  Hybrid packaging  ·  Agent-to-agent handoff</a:t>
+              <a:t>C-Batch  ·  Hybrid packaging  ·  Agent handoff  ·  Security-hardened</a:t>
             </a:r>
           </a:p>
         </p:txBody>
@@ -3316,7 +3316,7 @@
                 </a:solidFill>
                 <a:latin typeface="Calibri"/>
               </a:rPr>
-              <a:t>pip install promptcapsule   ·   github.com/UdayaNirogi/promptcapsule</a:t>
+              <a:t>pip install promptcapsule==0.1.4   ·   github.com/UdayaNirogi/promptcapsule</a:t>
             </a:r>
           </a:p>
         </p:txBody>
@@ -4222,7 +4222,7 @@
                 </a:solidFill>
                 <a:latin typeface="Calibri"/>
               </a:rPr>
-              <a:t>~99%</a:t>
+              <a:t>10 MiB</a:t>
             </a:r>
           </a:p>
         </p:txBody>
@@ -4257,7 +4257,7 @@
                 </a:solidFill>
                 <a:latin typeface="Calibri"/>
               </a:rPr>
-              <a:t>Smaller vault handle vs long prompt</a:t>
+              <a:t>Max prompt / zlib expand</a:t>
             </a:r>
           </a:p>
         </p:txBody>
@@ -4372,7 +4372,7 @@
                 </a:solidFill>
                 <a:latin typeface="Calibri"/>
               </a:rPr>
-              <a:t>Integrity on every decompress</a:t>
+              <a:t>Fail-closed integrity</a:t>
             </a:r>
           </a:p>
         </p:txBody>
@@ -4452,7 +4452,7 @@
                 </a:solidFill>
                 <a:latin typeface="Calibri"/>
               </a:rPr>
-              <a:t>100%</a:t>
+              <a:t>81</a:t>
             </a:r>
           </a:p>
         </p:txBody>
@@ -4487,7 +4487,7 @@
                 </a:solidFill>
                 <a:latin typeface="Calibri"/>
               </a:rPr>
-              <a:t>Lossless when verified</a:t>
+              <a:t>Automated tests</a:t>
             </a:r>
           </a:p>
         </p:txBody>
@@ -4682,7 +4682,7 @@
                 </a:solidFill>
                 <a:latin typeface="Calibri"/>
               </a:rPr>
-              <a:t>27+</a:t>
+              <a:t>0.1.4</a:t>
             </a:r>
           </a:p>
         </p:txBody>
@@ -4717,7 +4717,7 @@
                 </a:solidFill>
                 <a:latin typeface="Calibri"/>
               </a:rPr>
-              <a:t>Automated test cases</a:t>
+              <a:t>Current release</a:t>
             </a:r>
           </a:p>
         </p:txBody>
@@ -5029,7 +5029,7 @@
                 </a:solidFill>
                 <a:latin typeface="Calibri"/>
               </a:rPr>
-              <a:t>5  ·  Quantified Results (measured on v0.1.0)</a:t>
+              <a:t>5  ·  Limits &amp; Security (v0.1.4)</a:t>
             </a:r>
           </a:p>
         </p:txBody>
@@ -5131,7 +5131,7 @@
                 </a:solidFill>
                 <a:latin typeface="Calibri"/>
               </a:rPr>
-              <a:t>Benchmark table</a:t>
+              <a:t>Hardening summary</a:t>
             </a:r>
           </a:p>
         </p:txBody>
@@ -5144,8 +5144,8 @@
         </p:nvSpPr>
         <p:spPr>
           <a:xfrm>
-            <a:off x="8046720" y="1280160"/>
-            <a:ext cx="3657600" cy="4389120"/>
+            <a:off x="8046720" y="1234440"/>
+            <a:ext cx="3657600" cy="4572000"/>
           </a:xfrm>
           <a:prstGeom prst="rect">
             <a:avLst/>
@@ -5160,23 +5160,27 @@
           <a:p>
             <a:pPr algn="l"/>
             <a:r>
-              <a:rPr sz="1300" b="0">
+              <a:rPr sz="1200" b="0">
                 <a:solidFill>
                   <a:srgbClr val="0B1F3A"/>
                 </a:solidFill>
                 <a:latin typeface="Calibri"/>
               </a:rPr>
-              <a:t>Short 251 → 248 (inline)
-Near 307 → 288 (inline)
-RAG ~3KB → short vault key
-Multi-shot → short vault key
-Format:
-cap_i_&lt;hash8&gt;_&lt;b85&gt;
-cap_v_&lt;hash8&gt;_&lt;key&gt;
-27+ = test cases (QA)
-NOT capsule character count
-Vault key length varies
-by backend (mem/sql/gist/s3)</a:t>
+              <a:t>Limits:
+• Inline ≤ 500 bytes
+• Max size 10 MiB
+Fixed (library):
+• Fail-closed IntegrityError
+• Empty prefix rejected
+• zlib expansion capped
+• Unguessable vault keys
+• Vault leak redacted
+• Base85 junk rejected
+• S3 prefix + Gist owner
+Still not:
+• Encryption / auth / MAC
+• Demo HTTP bus (OOS)
+81 automated tests</a:t>
             </a:r>
           </a:p>
         </p:txBody>
@@ -5988,8 +5992,8 @@
                 </a:solidFill>
                 <a:latin typeface="Calibri"/>
               </a:rPr>
-              <a:t>Agent B acts only if verified=True.
-SHA-256 proves the prompt was not altered.</a:t>
+              <a:t>strict=True → IntegrityError on fail.
+Vault bind failure returns empty text.</a:t>
             </a:r>
           </a:p>
         </p:txBody>
@@ -6024,9 +6028,9 @@
                 </a:solidFill>
                 <a:latin typeface="Calibri"/>
               </a:rPr>
-              <a:t>What this is: a payload format on top of the existing API — not a new agent protocol, and not encryption.
-Both agents must share the same vault for vault-mode capsules. Inline capsules travel alone.
-Backends: InMemory (tests) · SQLite (local) · GitHub Gist (team) · S3 (production). 27+ tests cover the library, not a fixed capsule length.</a:t>
+              <a:t>v0.1.4: not encryption / not auth. Capsule = payload format. Gist require_owner=True by default.
+Both agents must share the same vault for vault-mode. Inline capsules travel alone.
+81 tests. Historical “27+” = core test count, not capsule length.</a:t>
             </a:r>
           </a:p>
         </p:txBody>
@@ -6192,10 +6196,10 @@
                 </a:solidFill>
                 <a:latin typeface="Calibri"/>
               </a:rPr>
-              <a:t>→  PromptCapsule = lossless packaging + optional vault retrieval
-→  Agent-to-agent: pass a capsule, reconstruct the exact prompt, gate on verified
-→  Quantified: ≤500B inline; long prompts → short vault keys (~99% smaller handle)
-→  Quality: 27+ automated test cases — that number is tests, not capsule length</a:t>
+              <a:t>→  PromptCapsule v0.1.4 = lossless packaging + vault retrieval + fail-closed integrity
+→  Limits: ≤500B inline · 10 MiB max prompt/zlib · unguessable vault keys
+→  Agent handoff: decompress(strict=True); treat IntegrityError as reject
+→  Not encryption / not MAC — protect vault ACLs; 81 automated tests on PyPI</a:t>
             </a:r>
           </a:p>
         </p:txBody>
@@ -6265,10 +6269,10 @@
                 </a:solidFill>
                 <a:latin typeface="Calibri"/>
               </a:rPr>
-              <a:t>pip install promptcapsule
+              <a:t>pip install promptcapsule==0.1.4
 https://github.com/UdayaNirogi/promptcapsule
-https://pypi.org/project/promptcapsule/
-Docs: ABSTRACT.md · TECHNICAL_DESIGN.md</a:t>
+https://pypi.org/project/promptcapsule/0.1.4/
+Docs: ABSTRACT.md · TECHNICAL_DESIGN.md · README security section</a:t>
             </a:r>
           </a:p>
         </p:txBody>

</xml_diff>

<commit_message>
Docs 0.1.5: 81 tests, plain-language limits, drop public F-codes
Clarify PyPI/README and design docs: real test count, limitations,
fixed vs open security items. Keep finding IDs only in securityReview.
Regenerate C-batch PPT for v0.1.5.

Co-authored-by: Cursor <cursoragent@cursor.com>
</commit_message>
<xml_diff>
--- a/presentation/PromptCapsule_CBatch.pptx
+++ b/presentation/PromptCapsule_CBatch.pptx
@@ -3246,7 +3246,7 @@
                 </a:solidFill>
                 <a:latin typeface="Calibri"/>
               </a:rPr>
-              <a:t>Lossless Prompt Packaging &amp; Retrieval  ·  v0.1.4</a:t>
+              <a:t>Lossless Prompt Packaging &amp; Retrieval  ·  v0.1.5</a:t>
             </a:r>
           </a:p>
         </p:txBody>
@@ -3316,7 +3316,7 @@
                 </a:solidFill>
                 <a:latin typeface="Calibri"/>
               </a:rPr>
-              <a:t>pip install promptcapsule==0.1.4   ·   github.com/UdayaNirogi/promptcapsule</a:t>
+              <a:t>pip install promptcapsule==0.1.5   ·   github.com/UdayaNirogi/promptcapsule</a:t>
             </a:r>
           </a:p>
         </p:txBody>
@@ -4027,7 +4027,7 @@
                 </a:solidFill>
                 <a:latin typeface="Calibri"/>
               </a:rPr>
-              <a:t>Abstract: PromptCapsule is a Python library that turns LLM prompt text into a portable capsule string and reconstructs the original byte-for-byte. Inline mode (≤500 bytes) uses zlib+Base85; vault mode stores long prompts and returns a short backend key (~99% smaller shareable handle). Every decompress returns verified SHA-256 integrity. Quality: 27+ automated test cases.</a:t>
+              <a:t>Abstract: PromptCapsule turns LLM prompt text into a portable capsule and reconstructs it byte-for-byte. Inline (≤500 bytes): zlib+Base85. Vault (&gt;500 bytes): short key into a shared store. Limits: 10 MiB max prompt/zlib. Default decompress is fail-closed. Suite: 81 automated tests.</a:t>
             </a:r>
           </a:p>
         </p:txBody>
@@ -4257,7 +4257,7 @@
                 </a:solidFill>
                 <a:latin typeface="Calibri"/>
               </a:rPr>
-              <a:t>Max prompt / zlib expand</a:t>
+              <a:t>Max prompt / zlib</a:t>
             </a:r>
           </a:p>
         </p:txBody>
@@ -4372,7 +4372,7 @@
                 </a:solidFill>
                 <a:latin typeface="Calibri"/>
               </a:rPr>
-              <a:t>Fail-closed integrity</a:t>
+              <a:t>Fail-closed verify</a:t>
             </a:r>
           </a:p>
         </p:txBody>
@@ -4682,7 +4682,7 @@
                 </a:solidFill>
                 <a:latin typeface="Calibri"/>
               </a:rPr>
-              <a:t>0.1.4</a:t>
+              <a:t>0.1.5</a:t>
             </a:r>
           </a:p>
         </p:txBody>
@@ -5029,7 +5029,7 @@
                 </a:solidFill>
                 <a:latin typeface="Calibri"/>
               </a:rPr>
-              <a:t>5  ·  Limits &amp; Security (v0.1.4)</a:t>
+              <a:t>5  ·  Limits &amp; Security</a:t>
             </a:r>
           </a:p>
         </p:txBody>
@@ -5169,17 +5169,19 @@
               <a:t>Limits:
 • Inline ≤ 500 bytes
 • Max size 10 MiB
-Fixed (library):
+Fixed in library:
 • Fail-closed IntegrityError
-• Empty prefix rejected
+• Invalid prefixes rejected
 • zlib expansion capped
 • Unguessable vault keys
-• Vault leak redacted
+• No vault plaintext leak
 • Base85 junk rejected
 • S3 prefix + Gist owner
-Still not:
-• Encryption / auth / MAC
-• Demo HTTP bus (OOS)
+Still limitations:
+• Not encryption
+• Not authentication
+• Not a full MAC
+• Demo HTTP bus OOS
 81 automated tests</a:t>
             </a:r>
           </a:p>
@@ -6028,9 +6030,9 @@
                 </a:solidFill>
                 <a:latin typeface="Calibri"/>
               </a:rPr>
-              <a:t>v0.1.4: not encryption / not auth. Capsule = payload format. Gist require_owner=True by default.
+              <a:t>v0.1.5: packaging + retrieval — not encryption / not auth. Gist require_owner by default.
 Both agents must share the same vault for vault-mode. Inline capsules travel alone.
-81 tests. Historical “27+” = core test count, not capsule length.</a:t>
+Automated test suite: 81 tests (core + security).</a:t>
             </a:r>
           </a:p>
         </p:txBody>
@@ -6196,10 +6198,10 @@
                 </a:solidFill>
                 <a:latin typeface="Calibri"/>
               </a:rPr>
-              <a:t>→  PromptCapsule v0.1.4 = lossless packaging + vault retrieval + fail-closed integrity
-→  Limits: ≤500B inline · 10 MiB max prompt/zlib · unguessable vault keys
-→  Agent handoff: decompress(strict=True); treat IntegrityError as reject
-→  Not encryption / not MAC — protect vault ACLs; 81 automated tests on PyPI</a:t>
+              <a:t>→  PromptCapsule = lossless packaging + vault retrieval + fail-closed integrity
+→  Limits: ≤500B inline · 10 MiB max · unguessable keys · 81 automated tests
+→  Open limitations: not encryption, not auth, 8-hex checksum is not a MAC
+→  Agent pattern: decompress(strict=True); reject on IntegrityError</a:t>
             </a:r>
           </a:p>
         </p:txBody>
@@ -6269,10 +6271,10 @@
                 </a:solidFill>
                 <a:latin typeface="Calibri"/>
               </a:rPr>
-              <a:t>pip install promptcapsule==0.1.4
+              <a:t>pip install promptcapsule==0.1.5
 https://github.com/UdayaNirogi/promptcapsule
-https://pypi.org/project/promptcapsule/0.1.4/
-Docs: ABSTRACT.md · TECHNICAL_DESIGN.md · README security section</a:t>
+https://pypi.org/project/promptcapsule/0.1.5/
+Docs: ABSTRACT.md · TECHNICAL_DESIGN.md · README (limits &amp; security)</a:t>
             </a:r>
           </a:p>
         </p:txBody>

</xml_diff>